<commit_message>
feat: replace figure 2-2 placeholder with real evidence
</commit_message>
<xml_diff>
--- a/docs/figures/system/traceguard_figures.pptx
+++ b/docs/figures/system/traceguard_figures.pptx
@@ -7173,7 +7173,6 @@
             <a:solidFill>
               <a:srgbClr val="5E5E5E"/>
             </a:solidFill>
-            <a:prstDash val="dash"/>
           </a:ln>
           <a:effectLst/>
         </p:spPr>
@@ -7199,275 +7198,33 @@
           </a:p>
         </p:txBody>
       </p:sp>
-      <p:sp>
-        <p:nvSpPr>
-          <p:cNvPr id="3" name="Rectangle 2"/>
-          <p:cNvSpPr/>
-          <p:nvPr/>
-        </p:nvSpPr>
-        <p:spPr>
-          <a:xfrm>
-            <a:off x="1339595" y="2377440"/>
-            <a:ext cx="1828800" cy="1554480"/>
+      <p:pic>
+        <p:nvPicPr>
+          <p:cNvPr id="3" name="Picture 2" descr="detection_input_real.png"/>
+          <p:cNvPicPr>
+            <a:picLocks noChangeAspect="1"/>
+          </p:cNvPicPr>
+          <p:nvPr/>
+        </p:nvPicPr>
+        <p:blipFill>
+          <a:blip r:embed="rId2"/>
+          <a:stretch>
+            <a:fillRect/>
+          </a:stretch>
+        </p:blipFill>
+        <p:spPr>
+          <a:xfrm>
+            <a:off x="1005840" y="2157983"/>
+            <a:ext cx="2496312" cy="2496312"/>
           </a:xfrm>
           <a:prstGeom prst="rect">
             <a:avLst/>
           </a:prstGeom>
-          <a:solidFill>
-            <a:srgbClr val="FFFFFF"/>
-          </a:solidFill>
-          <a:ln w="17780">
-            <a:solidFill>
-              <a:srgbClr val="5E5E5E"/>
-            </a:solidFill>
-          </a:ln>
-          <a:effectLst/>
-        </p:spPr>
-        <p:style>
-          <a:lnRef idx="1">
-            <a:schemeClr val="accent1"/>
-          </a:lnRef>
-          <a:fillRef idx="3">
-            <a:schemeClr val="accent1"/>
-          </a:fillRef>
-          <a:effectRef idx="2">
-            <a:schemeClr val="accent1"/>
-          </a:effectRef>
-          <a:fontRef idx="minor">
-            <a:schemeClr val="lt1"/>
-          </a:fontRef>
-        </p:style>
-        <p:txBody>
-          <a:bodyPr rtlCol="0" anchor="ctr"/>
-          <a:lstStyle/>
-          <a:p>
-            <a:pPr algn="ctr"/>
-          </a:p>
-        </p:txBody>
-      </p:sp>
-      <p:sp>
-        <p:nvSpPr>
-          <p:cNvPr id="4" name="Rectangle 3"/>
-          <p:cNvSpPr/>
-          <p:nvPr/>
-        </p:nvSpPr>
-        <p:spPr>
-          <a:xfrm>
-            <a:off x="1394460" y="2432304"/>
-            <a:ext cx="1719072" cy="854964"/>
-          </a:xfrm>
-          <a:prstGeom prst="rect">
-            <a:avLst/>
-          </a:prstGeom>
-          <a:solidFill>
-            <a:srgbClr val="DCEBF7"/>
-          </a:solidFill>
-          <a:ln>
-            <a:noFill/>
-          </a:ln>
-          <a:effectLst/>
-        </p:spPr>
-        <p:style>
-          <a:lnRef idx="1">
-            <a:schemeClr val="accent1"/>
-          </a:lnRef>
-          <a:fillRef idx="3">
-            <a:schemeClr val="accent1"/>
-          </a:fillRef>
-          <a:effectRef idx="2">
-            <a:schemeClr val="accent1"/>
-          </a:effectRef>
-          <a:fontRef idx="minor">
-            <a:schemeClr val="lt1"/>
-          </a:fontRef>
-        </p:style>
-        <p:txBody>
-          <a:bodyPr rtlCol="0" anchor="ctr"/>
-          <a:lstStyle/>
-          <a:p>
-            <a:pPr algn="ctr"/>
-          </a:p>
-        </p:txBody>
-      </p:sp>
-      <p:sp>
-        <p:nvSpPr>
-          <p:cNvPr id="5" name="Oval 4"/>
-          <p:cNvSpPr/>
-          <p:nvPr/>
-        </p:nvSpPr>
-        <p:spPr>
-          <a:xfrm>
-            <a:off x="2473452" y="2595067"/>
-            <a:ext cx="329184" cy="329184"/>
-          </a:xfrm>
-          <a:prstGeom prst="ellipse">
-            <a:avLst/>
-          </a:prstGeom>
-          <a:solidFill>
-            <a:srgbClr val="F6C74B"/>
-          </a:solidFill>
-          <a:ln>
-            <a:noFill/>
-          </a:ln>
-          <a:effectLst/>
-        </p:spPr>
-        <p:style>
-          <a:lnRef idx="1">
-            <a:schemeClr val="accent1"/>
-          </a:lnRef>
-          <a:fillRef idx="3">
-            <a:schemeClr val="accent1"/>
-          </a:fillRef>
-          <a:effectRef idx="2">
-            <a:schemeClr val="accent1"/>
-          </a:effectRef>
-          <a:fontRef idx="minor">
-            <a:schemeClr val="lt1"/>
-          </a:fontRef>
-        </p:style>
-        <p:txBody>
-          <a:bodyPr rtlCol="0" anchor="ctr"/>
-          <a:lstStyle/>
-          <a:p>
-            <a:pPr algn="ctr"/>
-          </a:p>
-        </p:txBody>
-      </p:sp>
-      <p:sp>
-        <p:nvSpPr>
-          <p:cNvPr id="6" name="Isosceles Triangle 5"/>
-          <p:cNvSpPr/>
-          <p:nvPr/>
-        </p:nvSpPr>
-        <p:spPr>
-          <a:xfrm>
-            <a:off x="1559051" y="2843784"/>
-            <a:ext cx="914400" cy="621792"/>
-          </a:xfrm>
-          <a:prstGeom prst="triangle">
-            <a:avLst/>
-          </a:prstGeom>
-          <a:solidFill>
-            <a:srgbClr val="7FB06E"/>
-          </a:solidFill>
-          <a:ln>
-            <a:noFill/>
-          </a:ln>
-          <a:effectLst/>
-        </p:spPr>
-        <p:style>
-          <a:lnRef idx="1">
-            <a:schemeClr val="accent1"/>
-          </a:lnRef>
-          <a:fillRef idx="3">
-            <a:schemeClr val="accent1"/>
-          </a:fillRef>
-          <a:effectRef idx="2">
-            <a:schemeClr val="accent1"/>
-          </a:effectRef>
-          <a:fontRef idx="minor">
-            <a:schemeClr val="lt1"/>
-          </a:fontRef>
-        </p:style>
-        <p:txBody>
-          <a:bodyPr rtlCol="0" anchor="ctr"/>
-          <a:lstStyle/>
-          <a:p>
-            <a:pPr algn="ctr"/>
-          </a:p>
-        </p:txBody>
-      </p:sp>
-      <p:sp>
-        <p:nvSpPr>
-          <p:cNvPr id="7" name="Isosceles Triangle 6"/>
-          <p:cNvSpPr/>
-          <p:nvPr/>
-        </p:nvSpPr>
-        <p:spPr>
-          <a:xfrm>
-            <a:off x="2107691" y="2905963"/>
-            <a:ext cx="804672" cy="559612"/>
-          </a:xfrm>
-          <a:prstGeom prst="triangle">
-            <a:avLst/>
-          </a:prstGeom>
-          <a:solidFill>
-            <a:srgbClr val="5F9354"/>
-          </a:solidFill>
-          <a:ln>
-            <a:noFill/>
-          </a:ln>
-          <a:effectLst/>
-        </p:spPr>
-        <p:style>
-          <a:lnRef idx="1">
-            <a:schemeClr val="accent1"/>
-          </a:lnRef>
-          <a:fillRef idx="3">
-            <a:schemeClr val="accent1"/>
-          </a:fillRef>
-          <a:effectRef idx="2">
-            <a:schemeClr val="accent1"/>
-          </a:effectRef>
-          <a:fontRef idx="minor">
-            <a:schemeClr val="lt1"/>
-          </a:fontRef>
-        </p:style>
-        <p:txBody>
-          <a:bodyPr rtlCol="0" anchor="ctr"/>
-          <a:lstStyle/>
-          <a:p>
-            <a:pPr algn="ctr"/>
-          </a:p>
-        </p:txBody>
-      </p:sp>
-      <p:sp>
-        <p:nvSpPr>
-          <p:cNvPr id="8" name="Rectangle 7"/>
-          <p:cNvSpPr/>
-          <p:nvPr/>
-        </p:nvSpPr>
-        <p:spPr>
-          <a:xfrm>
-            <a:off x="1394460" y="3341217"/>
-            <a:ext cx="1719072" cy="497433"/>
-          </a:xfrm>
-          <a:prstGeom prst="rect">
-            <a:avLst/>
-          </a:prstGeom>
-          <a:solidFill>
-            <a:srgbClr val="E9E3CF"/>
-          </a:solidFill>
-          <a:ln>
-            <a:noFill/>
-          </a:ln>
-          <a:effectLst/>
-        </p:spPr>
-        <p:style>
-          <a:lnRef idx="1">
-            <a:schemeClr val="accent1"/>
-          </a:lnRef>
-          <a:fillRef idx="3">
-            <a:schemeClr val="accent1"/>
-          </a:fillRef>
-          <a:effectRef idx="2">
-            <a:schemeClr val="accent1"/>
-          </a:effectRef>
-          <a:fontRef idx="minor">
-            <a:schemeClr val="lt1"/>
-          </a:fontRef>
-        </p:style>
-        <p:txBody>
-          <a:bodyPr rtlCol="0" anchor="ctr"/>
-          <a:lstStyle/>
-          <a:p>
-            <a:pPr algn="ctr"/>
-          </a:p>
-        </p:txBody>
-      </p:sp>
-      <p:sp>
-        <p:nvSpPr>
-          <p:cNvPr id="9" name="TextBox 8"/>
+        </p:spPr>
+      </p:pic>
+      <p:sp>
+        <p:nvSpPr>
+          <p:cNvPr id="4" name="TextBox 3"/>
           <p:cNvSpPr txBox="1"/>
           <p:nvPr/>
         </p:nvSpPr>
@@ -7508,7 +7265,7 @@
       </p:sp>
       <p:sp>
         <p:nvSpPr>
-          <p:cNvPr id="10" name="TextBox 9"/>
+          <p:cNvPr id="5" name="TextBox 4"/>
           <p:cNvSpPr txBox="1"/>
           <p:nvPr/>
         </p:nvSpPr>
@@ -7542,14 +7299,14 @@
                 <a:ea typeface="Microsoft YaHei"/>
                 <a:cs typeface="Microsoft YaHei"/>
               </a:rPr>
-              <a:t>（示意样式，待填真实截图）</a:t>
-            </a:r>
-          </a:p>
-        </p:txBody>
-      </p:sp>
-      <p:sp>
-        <p:nvSpPr>
-          <p:cNvPr id="11" name="Rounded Rectangle 10"/>
+              <a:t>固定测试样例</a:t>
+            </a:r>
+          </a:p>
+        </p:txBody>
+      </p:sp>
+      <p:sp>
+        <p:nvSpPr>
+          <p:cNvPr id="6" name="Rounded Rectangle 5"/>
           <p:cNvSpPr/>
           <p:nvPr/>
         </p:nvSpPr>
@@ -7570,7 +7327,6 @@
             <a:solidFill>
               <a:srgbClr val="5E5E5E"/>
             </a:solidFill>
-            <a:prstDash val="dash"/>
           </a:ln>
           <a:effectLst/>
         </p:spPr>
@@ -7598,14 +7354,14 @@
       </p:sp>
       <p:pic>
         <p:nvPicPr>
-          <p:cNvPr id="12" name="Picture 11" descr="gradcam.png"/>
+          <p:cNvPr id="7" name="Picture 6" descr="detection_gradcam_real.png"/>
           <p:cNvPicPr>
             <a:picLocks noChangeAspect="1"/>
           </p:cNvPicPr>
           <p:nvPr/>
         </p:nvPicPr>
         <p:blipFill>
-          <a:blip r:embed="rId2"/>
+          <a:blip r:embed="rId3"/>
           <a:stretch>
             <a:fillRect/>
           </a:stretch>
@@ -7618,14 +7374,11 @@
           <a:prstGeom prst="rect">
             <a:avLst/>
           </a:prstGeom>
-          <a:ln>
-            <a:noFill/>
-          </a:ln>
         </p:spPr>
       </p:pic>
       <p:sp>
         <p:nvSpPr>
-          <p:cNvPr id="13" name="TextBox 12"/>
+          <p:cNvPr id="8" name="TextBox 7"/>
           <p:cNvSpPr txBox="1"/>
           <p:nvPr/>
         </p:nvSpPr>
@@ -7666,7 +7419,7 @@
       </p:sp>
       <p:sp>
         <p:nvSpPr>
-          <p:cNvPr id="14" name="TextBox 13"/>
+          <p:cNvPr id="9" name="TextBox 8"/>
           <p:cNvSpPr txBox="1"/>
           <p:nvPr/>
         </p:nvSpPr>
@@ -7700,14 +7453,14 @@
                 <a:ea typeface="Microsoft YaHei"/>
                 <a:cs typeface="Microsoft YaHei"/>
               </a:rPr>
-              <a:t>（示意样式，待填真实截图）</a:t>
-            </a:r>
-          </a:p>
-        </p:txBody>
-      </p:sp>
-      <p:sp>
-        <p:nvSpPr>
-          <p:cNvPr id="15" name="Rounded Rectangle 14"/>
+              <a:t>实测热力响应</a:t>
+            </a:r>
+          </a:p>
+        </p:txBody>
+      </p:sp>
+      <p:sp>
+        <p:nvSpPr>
+          <p:cNvPr id="10" name="Rounded Rectangle 9"/>
           <p:cNvSpPr/>
           <p:nvPr/>
         </p:nvSpPr>
@@ -7728,7 +7481,6 @@
             <a:solidFill>
               <a:srgbClr val="5E5E5E"/>
             </a:solidFill>
-            <a:prstDash val="dash"/>
           </a:ln>
           <a:effectLst/>
         </p:spPr>
@@ -7756,14 +7508,14 @@
       </p:sp>
       <p:pic>
         <p:nvPicPr>
-          <p:cNvPr id="16" name="Picture 15" descr="bbox.png"/>
+          <p:cNvPr id="11" name="Picture 10" descr="detection_bbox_real.png"/>
           <p:cNvPicPr>
             <a:picLocks noChangeAspect="1"/>
           </p:cNvPicPr>
           <p:nvPr/>
         </p:nvPicPr>
         <p:blipFill>
-          <a:blip r:embed="rId3"/>
+          <a:blip r:embed="rId4"/>
           <a:stretch>
             <a:fillRect/>
           </a:stretch>
@@ -7776,14 +7528,11 @@
           <a:prstGeom prst="rect">
             <a:avLst/>
           </a:prstGeom>
-          <a:ln>
-            <a:noFill/>
-          </a:ln>
         </p:spPr>
       </p:pic>
       <p:sp>
         <p:nvSpPr>
-          <p:cNvPr id="17" name="TextBox 16"/>
+          <p:cNvPr id="12" name="TextBox 11"/>
           <p:cNvSpPr txBox="1"/>
           <p:nvPr/>
         </p:nvSpPr>
@@ -7824,7 +7573,7 @@
       </p:sp>
       <p:sp>
         <p:nvSpPr>
-          <p:cNvPr id="18" name="TextBox 17"/>
+          <p:cNvPr id="13" name="TextBox 12"/>
           <p:cNvSpPr txBox="1"/>
           <p:nvPr/>
         </p:nvSpPr>
@@ -7858,14 +7607,14 @@
                 <a:ea typeface="Microsoft YaHei"/>
                 <a:cs typeface="Microsoft YaHei"/>
               </a:rPr>
-              <a:t>（示意样式，待填真实截图）</a:t>
-            </a:r>
-          </a:p>
-        </p:txBody>
-      </p:sp>
-      <p:sp>
-        <p:nvSpPr>
-          <p:cNvPr id="19" name="TextBox 18"/>
+              <a:t>实测定位结果</a:t>
+            </a:r>
+          </a:p>
+        </p:txBody>
+      </p:sp>
+      <p:sp>
+        <p:nvSpPr>
+          <p:cNvPr id="14" name="TextBox 13"/>
           <p:cNvSpPr txBox="1"/>
           <p:nvPr/>
         </p:nvSpPr>
@@ -7899,7 +7648,7 @@
                 <a:ea typeface="Microsoft YaHei"/>
                 <a:cs typeface="Microsoft YaHei"/>
               </a:rPr>
-              <a:t>占位：示意图仅表示每格应呈现的内容形态，最终由成员填入真实检测截图，不得伪造检测结果。</a:t>
+              <a:t>实测样例：正式权重、CUDA 推理；全局判断与局部证据分别保留。</a:t>
             </a:r>
           </a:p>
         </p:txBody>

</xml_diff>